<commit_message>
Presentation: PPT + Video
</commit_message>
<xml_diff>
--- a/!_presentation/Gruppe_5_Endpraesentation.pptx
+++ b/!_presentation/Gruppe_5_Endpraesentation.pptx
@@ -1927,7 +1927,7 @@
                 <a:ea typeface="Calibri" pitchFamily="34" charset="-122"/>
                 <a:cs typeface="Calibri" pitchFamily="34" charset="-120"/>
               </a:rPr>
-              <a:t>02.06.2026</a:t>
+              <a:t>19.06.2026</a:t>
             </a:r>
             <a:endParaRPr lang="en-US" sz="1400" dirty="0"/>
           </a:p>
@@ -2154,52 +2154,13 @@
       </p:sp>
       <p:sp>
         <p:nvSpPr>
-          <p:cNvPr id="4" name="Text 2"/>
-          <p:cNvSpPr/>
-          <p:nvPr/>
-        </p:nvSpPr>
-        <p:spPr>
-          <a:xfrm>
-            <a:off x="548640" y="1188720"/>
-            <a:ext cx="11064240" cy="457200"/>
-          </a:xfrm>
-          <a:prstGeom prst="rect">
-            <a:avLst/>
-          </a:prstGeom>
-          <a:noFill/>
-          <a:ln/>
-        </p:spPr>
-        <p:txBody>
-          <a:bodyPr wrap="square" lIns="0" tIns="0" rIns="0" bIns="0" rtlCol="0" anchor="ctr"/>
-          <a:lstStyle/>
-          <a:p>
-            <a:pPr marL="0" indent="0">
-              <a:buNone/>
-            </a:pPr>
-            <a:r>
-              <a:rPr lang="en-US" sz="1600" i="1" dirty="0">
-                <a:solidFill>
-                  <a:srgbClr val="6B7280"/>
-                </a:solidFill>
-                <a:latin typeface="Calibri" pitchFamily="34" charset="0"/>
-                <a:ea typeface="Calibri" pitchFamily="34" charset="-122"/>
-                <a:cs typeface="Calibri" pitchFamily="34" charset="-120"/>
-              </a:rPr>
-              <a:t>Wer das Muster kennt, kann planen statt reagieren.</a:t>
-            </a:r>
-            <a:endParaRPr lang="en-US" sz="1600" dirty="0"/>
-          </a:p>
-        </p:txBody>
-      </p:sp>
-      <p:sp>
-        <p:nvSpPr>
           <p:cNvPr id="5" name="Shape 3"/>
           <p:cNvSpPr/>
           <p:nvPr/>
         </p:nvSpPr>
         <p:spPr>
           <a:xfrm>
-            <a:off x="411480" y="1920240"/>
+            <a:off x="411480" y="1688749"/>
             <a:ext cx="3657600" cy="1920240"/>
           </a:xfrm>
           <a:prstGeom prst="rect">
@@ -2231,7 +2192,7 @@
         </p:nvSpPr>
         <p:spPr>
           <a:xfrm>
-            <a:off x="411480" y="1920240"/>
+            <a:off x="411480" y="1688749"/>
             <a:ext cx="3657600" cy="73152"/>
           </a:xfrm>
           <a:prstGeom prst="rect">
@@ -2263,7 +2224,7 @@
         </p:nvSpPr>
         <p:spPr>
           <a:xfrm>
-            <a:off x="411480" y="2194560"/>
+            <a:off x="411480" y="1963069"/>
             <a:ext cx="3657600" cy="822960"/>
           </a:xfrm>
           <a:prstGeom prst="rect">
@@ -2302,7 +2263,7 @@
         </p:nvSpPr>
         <p:spPr>
           <a:xfrm>
-            <a:off x="411480" y="3017520"/>
+            <a:off x="411480" y="2786029"/>
             <a:ext cx="3657600" cy="822960"/>
           </a:xfrm>
           <a:prstGeom prst="rect">
@@ -2391,7 +2352,7 @@
         </p:nvSpPr>
         <p:spPr>
           <a:xfrm>
-            <a:off x="4251960" y="1920240"/>
+            <a:off x="4251960" y="1688749"/>
             <a:ext cx="3657600" cy="1920240"/>
           </a:xfrm>
           <a:prstGeom prst="rect">
@@ -2423,7 +2384,7 @@
         </p:nvSpPr>
         <p:spPr>
           <a:xfrm>
-            <a:off x="4251960" y="1920240"/>
+            <a:off x="4251960" y="1688749"/>
             <a:ext cx="3657600" cy="73152"/>
           </a:xfrm>
           <a:prstGeom prst="rect">
@@ -2455,7 +2416,7 @@
         </p:nvSpPr>
         <p:spPr>
           <a:xfrm>
-            <a:off x="4251960" y="2194560"/>
+            <a:off x="4251960" y="1963069"/>
             <a:ext cx="3657600" cy="822960"/>
           </a:xfrm>
           <a:prstGeom prst="rect">
@@ -2494,7 +2455,7 @@
         </p:nvSpPr>
         <p:spPr>
           <a:xfrm>
-            <a:off x="4251960" y="3017520"/>
+            <a:off x="4251960" y="2786029"/>
             <a:ext cx="3657600" cy="822960"/>
           </a:xfrm>
           <a:prstGeom prst="rect">
@@ -2550,7 +2511,7 @@
         </p:nvSpPr>
         <p:spPr>
           <a:xfrm>
-            <a:off x="8092440" y="1920240"/>
+            <a:off x="8092440" y="1688749"/>
             <a:ext cx="3657600" cy="1920240"/>
           </a:xfrm>
           <a:prstGeom prst="rect">
@@ -2582,7 +2543,7 @@
         </p:nvSpPr>
         <p:spPr>
           <a:xfrm>
-            <a:off x="8092440" y="1920240"/>
+            <a:off x="8092440" y="1688749"/>
             <a:ext cx="3657600" cy="73152"/>
           </a:xfrm>
           <a:prstGeom prst="rect">
@@ -2614,7 +2575,7 @@
         </p:nvSpPr>
         <p:spPr>
           <a:xfrm>
-            <a:off x="8092440" y="2194560"/>
+            <a:off x="8092440" y="1963069"/>
             <a:ext cx="3657600" cy="822960"/>
           </a:xfrm>
           <a:prstGeom prst="rect">
@@ -2653,7 +2614,7 @@
         </p:nvSpPr>
         <p:spPr>
           <a:xfrm>
-            <a:off x="8092440" y="3017520"/>
+            <a:off x="8092440" y="2786029"/>
             <a:ext cx="3657600" cy="822960"/>
           </a:xfrm>
           <a:prstGeom prst="rect">
@@ -2801,7 +2762,7 @@
         </p:blipFill>
         <p:spPr>
           <a:xfrm>
-            <a:off x="1238034" y="3973903"/>
+            <a:off x="1238034" y="3950755"/>
             <a:ext cx="9715931" cy="2472617"/>
           </a:xfrm>
           <a:prstGeom prst="rect">
@@ -2953,7 +2914,29 @@
                 <a:ea typeface="Calibri" pitchFamily="34" charset="-122"/>
                 <a:cs typeface="Calibri" pitchFamily="34" charset="-120"/>
               </a:rPr>
-              <a:t>Zwei seriöse Quellen, stündlich kombiniert, reproduzierbar aufbereitet.</a:t>
+              <a:t>Zwei </a:t>
+            </a:r>
+            <a:r>
+              <a:rPr lang="en-US" sz="1600" i="1" dirty="0" err="1">
+                <a:solidFill>
+                  <a:srgbClr val="6B7280"/>
+                </a:solidFill>
+                <a:latin typeface="Calibri" pitchFamily="34" charset="0"/>
+                <a:ea typeface="Calibri" pitchFamily="34" charset="-122"/>
+                <a:cs typeface="Calibri" pitchFamily="34" charset="-120"/>
+              </a:rPr>
+              <a:t>Quellen</a:t>
+            </a:r>
+            <a:r>
+              <a:rPr lang="en-US" sz="1600" i="1" dirty="0">
+                <a:solidFill>
+                  <a:srgbClr val="6B7280"/>
+                </a:solidFill>
+                <a:latin typeface="Calibri" pitchFamily="34" charset="0"/>
+                <a:ea typeface="Calibri" pitchFamily="34" charset="-122"/>
+                <a:cs typeface="Calibri" pitchFamily="34" charset="-120"/>
+              </a:rPr>
+              <a:t>, stündlich kombiniert, reproduzierbar aufbereitet.</a:t>
             </a:r>
             <a:endParaRPr lang="en-US" sz="1600" dirty="0"/>
           </a:p>
@@ -3469,17 +3452,6 @@
             <a:pPr marL="0" indent="0" algn="ctr">
               <a:buNone/>
             </a:pPr>
-            <a:r>
-              <a:rPr lang="en-US" sz="1000" i="1" dirty="0">
-                <a:solidFill>
-                  <a:srgbClr val="6B7280"/>
-                </a:solidFill>
-                <a:latin typeface="Calibri" pitchFamily="34" charset="0"/>
-                <a:ea typeface="Calibri" pitchFamily="34" charset="-122"/>
-                <a:cs typeface="Calibri" pitchFamily="34" charset="-120"/>
-              </a:rPr>
-              <a:t>Pipeline und Code öffentlich auf GitHub dokumentiert</a:t>
-            </a:r>
             <a:endParaRPr lang="en-US" sz="1000" dirty="0"/>
           </a:p>
         </p:txBody>
@@ -3524,6 +3496,51 @@
                 <a:cs typeface="Calibri" pitchFamily="34" charset="-120"/>
               </a:rPr>
               <a:t>3 / 7</a:t>
+            </a:r>
+            <a:endParaRPr lang="en-US" sz="900" dirty="0"/>
+          </a:p>
+        </p:txBody>
+      </p:sp>
+      <p:sp>
+        <p:nvSpPr>
+          <p:cNvPr id="20" name="Text 20">
+            <a:extLst>
+              <a:ext uri="{FF2B5EF4-FFF2-40B4-BE49-F238E27FC236}">
+                <a16:creationId xmlns:a16="http://schemas.microsoft.com/office/drawing/2014/main" id="{4F572D0B-59CF-A964-2F40-05FA162DF7A1}"/>
+              </a:ext>
+            </a:extLst>
+          </p:cNvPr>
+          <p:cNvSpPr/>
+          <p:nvPr/>
+        </p:nvSpPr>
+        <p:spPr>
+          <a:xfrm>
+            <a:off x="548640" y="6492240"/>
+            <a:ext cx="7315200" cy="274320"/>
+          </a:xfrm>
+          <a:prstGeom prst="rect">
+            <a:avLst/>
+          </a:prstGeom>
+          <a:noFill/>
+          <a:ln/>
+        </p:spPr>
+        <p:txBody>
+          <a:bodyPr wrap="square" rtlCol="0" anchor="ctr"/>
+          <a:lstStyle/>
+          <a:p>
+            <a:pPr marL="0" indent="0" algn="l">
+              <a:buNone/>
+            </a:pPr>
+            <a:r>
+              <a:rPr lang="en-US" sz="900" dirty="0">
+                <a:solidFill>
+                  <a:srgbClr val="6B7280"/>
+                </a:solidFill>
+                <a:latin typeface="Calibri" pitchFamily="34" charset="0"/>
+                <a:ea typeface="Calibri" pitchFamily="34" charset="-122"/>
+                <a:cs typeface="Calibri" pitchFamily="34" charset="-120"/>
+              </a:rPr>
+              <a:t>Energy-Weather Project  ·  Management Brief</a:t>
             </a:r>
             <a:endParaRPr lang="en-US" sz="900" dirty="0"/>
           </a:p>
@@ -5686,10 +5703,111 @@
                 <a:ea typeface="Calibri" pitchFamily="34" charset="-122"/>
                 <a:cs typeface="Calibri" pitchFamily="34" charset="-120"/>
               </a:rPr>
-              <a:t>Interaktives Szenario-Tool produktiv</a:t>
-            </a:r>
-            <a:endParaRPr lang="en-US" sz="1500" dirty="0"/>
-          </a:p>
+              <a:t>Interaktives </a:t>
+            </a:r>
+            <a:r>
+              <a:rPr lang="en-US" sz="1500" dirty="0" err="1">
+                <a:solidFill>
+                  <a:srgbClr val="FFFFFF"/>
+                </a:solidFill>
+                <a:latin typeface="Calibri" pitchFamily="34" charset="0"/>
+                <a:ea typeface="Calibri" pitchFamily="34" charset="-122"/>
+                <a:cs typeface="Calibri" pitchFamily="34" charset="-120"/>
+              </a:rPr>
+              <a:t>Szenario</a:t>
+            </a:r>
+            <a:r>
+              <a:rPr lang="en-US" sz="1500" dirty="0">
+                <a:solidFill>
+                  <a:srgbClr val="FFFFFF"/>
+                </a:solidFill>
+                <a:latin typeface="Calibri" pitchFamily="34" charset="0"/>
+                <a:ea typeface="Calibri" pitchFamily="34" charset="-122"/>
+                <a:cs typeface="Calibri" pitchFamily="34" charset="-120"/>
+              </a:rPr>
+              <a:t>-Tool </a:t>
+            </a:r>
+            <a:r>
+              <a:rPr lang="en-US" sz="1500" dirty="0" err="1">
+                <a:solidFill>
+                  <a:srgbClr val="FFFFFF"/>
+                </a:solidFill>
+                <a:latin typeface="Calibri" pitchFamily="34" charset="0"/>
+                <a:ea typeface="Calibri" pitchFamily="34" charset="-122"/>
+                <a:cs typeface="Calibri" pitchFamily="34" charset="-120"/>
+              </a:rPr>
+              <a:t>produktiv</a:t>
+            </a:r>
+            <a:endParaRPr lang="en-US" sz="1500" dirty="0">
+              <a:solidFill>
+                <a:srgbClr val="FFFFFF"/>
+              </a:solidFill>
+              <a:latin typeface="Calibri" pitchFamily="34" charset="0"/>
+              <a:ea typeface="Calibri" pitchFamily="34" charset="-122"/>
+              <a:cs typeface="Calibri" pitchFamily="34" charset="-120"/>
+            </a:endParaRPr>
+          </a:p>
+        </p:txBody>
+      </p:sp>
+      <p:sp>
+        <p:nvSpPr>
+          <p:cNvPr id="7" name="Text 5"/>
+          <p:cNvSpPr/>
+          <p:nvPr/>
+        </p:nvSpPr>
+        <p:spPr>
+          <a:xfrm>
+            <a:off x="6400800" y="2286000"/>
+            <a:ext cx="5486400" cy="274320"/>
+          </a:xfrm>
+          <a:prstGeom prst="rect">
+            <a:avLst/>
+          </a:prstGeom>
+          <a:noFill/>
+          <a:ln/>
+        </p:spPr>
+        <p:txBody>
+          <a:bodyPr wrap="square" lIns="0" tIns="0" rIns="0" bIns="0" rtlCol="0" anchor="ctr"/>
+          <a:lstStyle/>
+          <a:p>
+            <a:pPr marL="0" indent="0">
+              <a:buNone/>
+            </a:pPr>
+            <a:r>
+              <a:rPr lang="en-US" sz="1100" b="1" kern="0" spc="400" dirty="0">
+                <a:solidFill>
+                  <a:srgbClr val="2E7DC1"/>
+                </a:solidFill>
+                <a:latin typeface="Calibri" pitchFamily="34" charset="0"/>
+                <a:ea typeface="Calibri" pitchFamily="34" charset="-122"/>
+                <a:cs typeface="Calibri" pitchFamily="34" charset="-120"/>
+              </a:rPr>
+              <a:t>ERWEITERBAR RICHTUNG</a:t>
+            </a:r>
+            <a:endParaRPr lang="en-US" sz="1100" dirty="0"/>
+          </a:p>
+        </p:txBody>
+      </p:sp>
+      <p:sp>
+        <p:nvSpPr>
+          <p:cNvPr id="8" name="Text 6"/>
+          <p:cNvSpPr/>
+          <p:nvPr/>
+        </p:nvSpPr>
+        <p:spPr>
+          <a:xfrm>
+            <a:off x="6400800" y="2697480"/>
+            <a:ext cx="5303520" cy="3200400"/>
+          </a:xfrm>
+          <a:prstGeom prst="rect">
+            <a:avLst/>
+          </a:prstGeom>
+          <a:noFill/>
+          <a:ln/>
+        </p:spPr>
+        <p:txBody>
+          <a:bodyPr wrap="square" lIns="0" tIns="0" rIns="0" bIns="0" rtlCol="0" anchor="t"/>
+          <a:lstStyle/>
           <a:p>
             <a:pPr marL="342900" indent="-342900">
               <a:spcAft>
@@ -5699,87 +5817,34 @@
               <a:buChar char="•"/>
             </a:pPr>
             <a:r>
+              <a:rPr lang="en-US" sz="1500" dirty="0" err="1">
+                <a:solidFill>
+                  <a:srgbClr val="FFFFFF"/>
+                </a:solidFill>
+                <a:latin typeface="Calibri" pitchFamily="34" charset="0"/>
+                <a:ea typeface="Calibri" pitchFamily="34" charset="-122"/>
+                <a:cs typeface="Calibri" pitchFamily="34" charset="-120"/>
+              </a:rPr>
+              <a:t>Echtzeit-Wetteranbindung</a:t>
+            </a:r>
+            <a:r>
+              <a:rPr lang="en-US" sz="1500" dirty="0"/>
+              <a:t> </a:t>
+            </a:r>
+            <a:r>
               <a:rPr lang="en-US" sz="1500" dirty="0">
                 <a:solidFill>
                   <a:srgbClr val="FFFFFF"/>
                 </a:solidFill>
                 <a:latin typeface="Calibri" pitchFamily="34" charset="0"/>
-                <a:ea typeface="Calibri" pitchFamily="34" charset="-122"/>
-                <a:cs typeface="Calibri" pitchFamily="34" charset="-120"/>
-              </a:rPr>
-              <a:t>Reproduzierbare Pipeline dokumentiert</a:t>
-            </a:r>
-            <a:endParaRPr lang="en-US" sz="1500" dirty="0"/>
-          </a:p>
-        </p:txBody>
-      </p:sp>
-      <p:sp>
-        <p:nvSpPr>
-          <p:cNvPr id="7" name="Text 5"/>
-          <p:cNvSpPr/>
-          <p:nvPr/>
-        </p:nvSpPr>
-        <p:spPr>
-          <a:xfrm>
-            <a:off x="6400800" y="2286000"/>
-            <a:ext cx="5486400" cy="274320"/>
-          </a:xfrm>
-          <a:prstGeom prst="rect">
-            <a:avLst/>
-          </a:prstGeom>
-          <a:noFill/>
-          <a:ln/>
-        </p:spPr>
-        <p:txBody>
-          <a:bodyPr wrap="square" lIns="0" tIns="0" rIns="0" bIns="0" rtlCol="0" anchor="ctr"/>
-          <a:lstStyle/>
-          <a:p>
-            <a:pPr marL="0" indent="0">
-              <a:buNone/>
-            </a:pPr>
-            <a:r>
-              <a:rPr lang="en-US" sz="1100" b="1" kern="0" spc="400" dirty="0">
-                <a:solidFill>
-                  <a:srgbClr val="2E7DC1"/>
-                </a:solidFill>
-                <a:latin typeface="Calibri" pitchFamily="34" charset="0"/>
-                <a:ea typeface="Calibri" pitchFamily="34" charset="-122"/>
-                <a:cs typeface="Calibri" pitchFamily="34" charset="-120"/>
-              </a:rPr>
-              <a:t>ERWEITERBAR RICHTUNG</a:t>
-            </a:r>
-            <a:endParaRPr lang="en-US" sz="1100" dirty="0"/>
-          </a:p>
-        </p:txBody>
-      </p:sp>
-      <p:sp>
-        <p:nvSpPr>
-          <p:cNvPr id="8" name="Text 6"/>
-          <p:cNvSpPr/>
-          <p:nvPr/>
-        </p:nvSpPr>
-        <p:spPr>
-          <a:xfrm>
-            <a:off x="6400800" y="2697480"/>
-            <a:ext cx="5303520" cy="3200400"/>
-          </a:xfrm>
-          <a:prstGeom prst="rect">
-            <a:avLst/>
-          </a:prstGeom>
-          <a:noFill/>
-          <a:ln/>
-        </p:spPr>
-        <p:txBody>
-          <a:bodyPr wrap="square" lIns="0" tIns="0" rIns="0" bIns="0" rtlCol="0" anchor="t"/>
-          <a:lstStyle/>
-          <a:p>
-            <a:pPr marL="342900" indent="-342900">
-              <a:spcAft>
-                <a:spcPts val="1000"/>
-              </a:spcAft>
-              <a:buSzPct val="100000"/>
-              <a:buChar char="•"/>
-            </a:pPr>
+                <a:cs typeface="Calibri" pitchFamily="34" charset="-120"/>
+              </a:rPr>
+              <a:t>für</a:t>
+            </a:r>
+            <a:r>
+              <a:rPr lang="en-US" sz="1500" dirty="0"/>
+              <a:t> </a:t>
+            </a:r>
             <a:r>
               <a:rPr lang="en-US" sz="1500" dirty="0">
                 <a:solidFill>
@@ -5789,28 +5854,7 @@
                 <a:ea typeface="Calibri" pitchFamily="34" charset="-122"/>
                 <a:cs typeface="Calibri" pitchFamily="34" charset="-120"/>
               </a:rPr>
-              <a:t>Echtzeit-Wetteranbindung</a:t>
-            </a:r>
-            <a:endParaRPr lang="en-US" sz="1500" dirty="0"/>
-          </a:p>
-          <a:p>
-            <a:pPr marL="342900" indent="-342900">
-              <a:spcAft>
-                <a:spcPts val="1000"/>
-              </a:spcAft>
-              <a:buSzPct val="100000"/>
-              <a:buChar char="•"/>
-            </a:pPr>
-            <a:r>
-              <a:rPr lang="en-US" sz="1500" dirty="0">
-                <a:solidFill>
-                  <a:srgbClr val="FFFFFF"/>
-                </a:solidFill>
-                <a:latin typeface="Calibri" pitchFamily="34" charset="0"/>
-                <a:ea typeface="Calibri" pitchFamily="34" charset="-122"/>
-                <a:cs typeface="Calibri" pitchFamily="34" charset="-120"/>
-              </a:rPr>
-              <a:t>Live-Prognose statt vorberechnet</a:t>
+              <a:t>Live-Prognose</a:t>
             </a:r>
             <a:endParaRPr lang="en-US" sz="1500" dirty="0"/>
           </a:p>

</xml_diff>